<commit_message>
修复三处关键 bug：PRM800K 改用全部人工标注 completions（原 chosen-only 致正类 99.8%）；metrics 统一 decision_function（修 balanced_acc/risk 退化）；Challenges 页如实标注 preliminary
</commit_message>
<xml_diff>
--- a/slides/final.pptx
+++ b/slides/final.pptx
@@ -3832,64 +3832,30 @@
           </a:p>
         </p:txBody>
       </p:sp>
-      <p:sp>
-        <p:nvSpPr>
-          <p:cNvPr id="3" name="Rectangle 2"/>
-          <p:cNvSpPr/>
+      <p:pic>
+        <p:nvPicPr>
+          <p:cNvPr id="3" name="Picture 2" descr="e1_learning_curve.png"/>
+          <p:cNvPicPr>
+            <a:picLocks noChangeAspect="1"/>
+          </p:cNvPicPr>
           <p:nvPr/>
-        </p:nvSpPr>
-        <p:spPr>
-          <a:xfrm>
-            <a:off x="2926080" y="1737360"/>
-            <a:ext cx="6309360" cy="2926080"/>
+        </p:nvPicPr>
+        <p:blipFill>
+          <a:blip r:embed="rId2"/>
+          <a:stretch>
+            <a:fillRect/>
+          </a:stretch>
+        </p:blipFill>
+        <p:spPr>
+          <a:xfrm>
+            <a:off x="2915644" y="1188720"/>
+            <a:ext cx="6360407" cy="4206240"/>
           </a:xfrm>
           <a:prstGeom prst="rect">
             <a:avLst/>
           </a:prstGeom>
-          <a:solidFill>
-            <a:srgbClr val="DDDDDD"/>
-          </a:solidFill>
-          <a:ln>
-            <a:solidFill>
-              <a:srgbClr val="999999"/>
-            </a:solidFill>
-          </a:ln>
-        </p:spPr>
-        <p:style>
-          <a:lnRef idx="1">
-            <a:schemeClr val="accent1"/>
-          </a:lnRef>
-          <a:fillRef idx="3">
-            <a:schemeClr val="accent1"/>
-          </a:fillRef>
-          <a:effectRef idx="2">
-            <a:schemeClr val="accent1"/>
-          </a:effectRef>
-          <a:fontRef idx="minor">
-            <a:schemeClr val="lt1"/>
-          </a:fontRef>
-        </p:style>
-        <p:txBody>
-          <a:bodyPr rtlCol="0" anchor="ctr"/>
-          <a:lstStyle/>
-          <a:p>
-            <a:pPr algn="ctr">
-              <a:defRPr sz="1600"/>
-            </a:pPr>
-            <a:r>
-              <a:t>[占位] e1_learning_curve.png</a:t>
-            </a:r>
-          </a:p>
-          <a:p>
-            <a:pPr algn="ctr">
-              <a:defRPr sz="1600"/>
-            </a:pPr>
-            <a:r>
-              <a:t>跑完实验后重跑 make_slides.py 自动嵌入</a:t>
-            </a:r>
-          </a:p>
-        </p:txBody>
-      </p:sp>
+        </p:spPr>
+      </p:pic>
       <p:sp>
         <p:nvSpPr>
           <p:cNvPr id="4" name="TextBox 3"/>
@@ -3898,7 +3864,7 @@
         </p:nvSpPr>
         <p:spPr>
           <a:xfrm>
-            <a:off x="640080" y="4846320"/>
+            <a:off x="640080" y="5486399"/>
             <a:ext cx="10911535" cy="1280160"/>
           </a:xfrm>
           <a:prstGeom prst="rect">
@@ -3974,64 +3940,30 @@
           </a:p>
         </p:txBody>
       </p:sp>
-      <p:sp>
-        <p:nvSpPr>
-          <p:cNvPr id="3" name="Rectangle 2"/>
-          <p:cNvSpPr/>
+      <p:pic>
+        <p:nvPicPr>
+          <p:cNvPr id="3" name="Picture 2" descr="e1_gap.png"/>
+          <p:cNvPicPr>
+            <a:picLocks noChangeAspect="1"/>
+          </p:cNvPicPr>
           <p:nvPr/>
-        </p:nvSpPr>
-        <p:spPr>
-          <a:xfrm>
-            <a:off x="2926080" y="1737360"/>
-            <a:ext cx="6309360" cy="2926080"/>
+        </p:nvPicPr>
+        <p:blipFill>
+          <a:blip r:embed="rId2"/>
+          <a:stretch>
+            <a:fillRect/>
+          </a:stretch>
+        </p:blipFill>
+        <p:spPr>
+          <a:xfrm>
+            <a:off x="2472400" y="1188720"/>
+            <a:ext cx="7246895" cy="4206240"/>
           </a:xfrm>
           <a:prstGeom prst="rect">
             <a:avLst/>
           </a:prstGeom>
-          <a:solidFill>
-            <a:srgbClr val="DDDDDD"/>
-          </a:solidFill>
-          <a:ln>
-            <a:solidFill>
-              <a:srgbClr val="999999"/>
-            </a:solidFill>
-          </a:ln>
-        </p:spPr>
-        <p:style>
-          <a:lnRef idx="1">
-            <a:schemeClr val="accent1"/>
-          </a:lnRef>
-          <a:fillRef idx="3">
-            <a:schemeClr val="accent1"/>
-          </a:fillRef>
-          <a:effectRef idx="2">
-            <a:schemeClr val="accent1"/>
-          </a:effectRef>
-          <a:fontRef idx="minor">
-            <a:schemeClr val="lt1"/>
-          </a:fontRef>
-        </p:style>
-        <p:txBody>
-          <a:bodyPr rtlCol="0" anchor="ctr"/>
-          <a:lstStyle/>
-          <a:p>
-            <a:pPr algn="ctr">
-              <a:defRPr sz="1600"/>
-            </a:pPr>
-            <a:r>
-              <a:t>[占位] e1_gap.png</a:t>
-            </a:r>
-          </a:p>
-          <a:p>
-            <a:pPr algn="ctr">
-              <a:defRPr sz="1600"/>
-            </a:pPr>
-            <a:r>
-              <a:t>跑完实验后重跑 make_slides.py 自动嵌入</a:t>
-            </a:r>
-          </a:p>
-        </p:txBody>
-      </p:sp>
+        </p:spPr>
+      </p:pic>
       <p:sp>
         <p:nvSpPr>
           <p:cNvPr id="4" name="TextBox 3"/>
@@ -4040,7 +3972,7 @@
         </p:nvSpPr>
         <p:spPr>
           <a:xfrm>
-            <a:off x="640080" y="4846320"/>
+            <a:off x="640080" y="5486399"/>
             <a:ext cx="10911535" cy="1280160"/>
           </a:xfrm>
           <a:prstGeom prst="rect">

</xml_diff>